<commit_message>
docs: add final preliminary materials
</commit_message>
<xml_diff>
--- a/初赛幻灯片.pptx
+++ b/初赛幻灯片.pptx
@@ -4448,7 +4448,7 @@
               <a:defRPr/>
             </a:pPr>
             <a:r>
-              <a:rPr lang="zh-CN" sz="1050" b="0">
+              <a:rPr lang="zh-CN" sz="1200" b="0">
                 <a:solidFill>
                   <a:schemeClr val="tx1"/>
                 </a:solidFill>
@@ -4458,7 +4458,7 @@
               </a:rPr>
               <a:t>inode · 目录 · Extent · 空间分配</a:t>
             </a:r>
-            <a:endParaRPr lang="zh-CN" sz="1050" b="0">
+            <a:endParaRPr lang="zh-CN" sz="1200" b="0">
               <a:solidFill>
                 <a:schemeClr val="tx1"/>
               </a:solidFill>
@@ -4593,7 +4593,7 @@
               <a:defRPr/>
             </a:pPr>
             <a:r>
-              <a:rPr lang="zh-CN" sz="1050" b="0">
+              <a:rPr lang="zh-CN" sz="1200" b="0">
                 <a:solidFill>
                   <a:schemeClr val="tx1"/>
                 </a:solidFill>
@@ -4603,7 +4603,7 @@
               </a:rPr>
               <a:t>事务 overlay · 提交 · 恢复</a:t>
             </a:r>
-            <a:endParaRPr lang="zh-CN" sz="1050" b="0">
+            <a:endParaRPr lang="zh-CN" sz="1200" b="0">
               <a:solidFill>
                 <a:schemeClr val="tx1"/>
               </a:solidFill>
@@ -4760,7 +4760,7 @@
               <a:defRPr/>
             </a:pPr>
             <a:r>
-              <a:rPr lang="zh-CN" sz="1050" b="0">
+              <a:rPr lang="zh-CN" sz="1200" b="0">
                 <a:solidFill>
                   <a:schemeClr val="tx1"/>
                 </a:solidFill>
@@ -4770,7 +4770,7 @@
               </a:rPr>
               <a:t>inode · dir · checkpoint 锁序</a:t>
             </a:r>
-            <a:endParaRPr lang="zh-CN" sz="1050" b="0">
+            <a:endParaRPr lang="zh-CN" sz="1200" b="0">
               <a:solidFill>
                 <a:schemeClr val="tx1"/>
               </a:solidFill>
@@ -4905,7 +4905,7 @@
               <a:defRPr/>
             </a:pPr>
             <a:r>
-              <a:rPr lang="zh-CN" sz="1050" b="0">
+              <a:rPr lang="zh-CN" sz="1200" b="0">
                 <a:solidFill>
                   <a:schemeClr val="tx1"/>
                 </a:solidFill>
@@ -4915,7 +4915,7 @@
               </a:rPr>
               <a:t>PageCache · 映射 · 设备块缓存</a:t>
             </a:r>
-            <a:endParaRPr lang="zh-CN" sz="1050" b="0">
+            <a:endParaRPr lang="zh-CN" sz="1200" b="0">
               <a:solidFill>
                 <a:schemeClr val="tx1"/>
               </a:solidFill>
@@ -5050,7 +5050,7 @@
               <a:defRPr/>
             </a:pPr>
             <a:r>
-              <a:rPr lang="zh-CN" sz="1050" b="0">
+              <a:rPr lang="zh-CN" sz="1200" b="0">
                 <a:solidFill>
                   <a:schemeClr val="tx1"/>
                 </a:solidFill>
@@ -5060,7 +5060,7 @@
               </a:rPr>
               <a:t>direct · buffered · journaled profiling</a:t>
             </a:r>
-            <a:endParaRPr lang="zh-CN" sz="1050" b="0">
+            <a:endParaRPr lang="zh-CN" sz="1200" b="0">
               <a:solidFill>
                 <a:schemeClr val="tx1"/>
               </a:solidFill>
@@ -5803,7 +5803,7 @@
               <a:defRPr/>
             </a:pPr>
             <a:r>
-              <a:rPr lang="zh-CN" sz="950">
+              <a:rPr lang="zh-CN" sz="1200">
                 <a:solidFill>
                   <a:schemeClr val="tx1"/>
                 </a:solidFill>
@@ -5813,7 +5813,7 @@
               </a:rPr>
               <a:t>发起写请求</a:t>
             </a:r>
-            <a:endParaRPr lang="zh-CN" sz="950">
+            <a:endParaRPr lang="zh-CN" sz="1200">
               <a:solidFill>
                 <a:schemeClr val="tx1"/>
               </a:solidFill>
@@ -5916,7 +5916,7 @@
               <a:defRPr/>
             </a:pPr>
             <a:r>
-              <a:rPr lang="zh-CN" sz="950">
+              <a:rPr lang="zh-CN" sz="1200">
                 <a:solidFill>
                   <a:schemeClr val="tx1"/>
                 </a:solidFill>
@@ -5926,7 +5926,7 @@
               </a:rPr>
               <a:t>进入文件系统</a:t>
             </a:r>
-            <a:endParaRPr lang="zh-CN" sz="950">
+            <a:endParaRPr lang="zh-CN" sz="1200">
               <a:solidFill>
                 <a:schemeClr val="tx1"/>
               </a:solidFill>
@@ -6029,7 +6029,7 @@
               <a:defRPr/>
             </a:pPr>
             <a:r>
-              <a:rPr lang="zh-CN" sz="950">
+              <a:rPr lang="zh-CN" sz="1200">
                 <a:solidFill>
                   <a:schemeClr val="tx1"/>
                 </a:solidFill>
@@ -6039,7 +6039,7 @@
               </a:rPr>
               <a:t>buffered 脏页</a:t>
             </a:r>
-            <a:endParaRPr lang="zh-CN" sz="950">
+            <a:endParaRPr lang="zh-CN" sz="1200">
               <a:solidFill>
                 <a:schemeClr val="tx1"/>
               </a:solidFill>
@@ -6142,7 +6142,7 @@
               <a:defRPr/>
             </a:pPr>
             <a:r>
-              <a:rPr lang="zh-CN" sz="950">
+              <a:rPr lang="zh-CN" sz="1200">
                 <a:solidFill>
                   <a:schemeClr val="tx1"/>
                 </a:solidFill>
@@ -6152,7 +6152,7 @@
               </a:rPr>
               <a:t>Extent 树插入/合并</a:t>
             </a:r>
-            <a:endParaRPr lang="zh-CN" sz="950">
+            <a:endParaRPr lang="zh-CN" sz="1200">
               <a:solidFill>
                 <a:schemeClr val="tx1"/>
               </a:solidFill>
@@ -6255,7 +6255,7 @@
               <a:defRPr/>
             </a:pPr>
             <a:r>
-              <a:rPr lang="zh-CN" sz="950">
+              <a:rPr lang="zh-CN" sz="1200">
                 <a:solidFill>
                   <a:schemeClr val="tx1"/>
                 </a:solidFill>
@@ -6265,7 +6265,7 @@
               </a:rPr>
               <a:t>数据落盘 + JBD2 提交元数据</a:t>
             </a:r>
-            <a:endParaRPr lang="zh-CN" sz="950">
+            <a:endParaRPr lang="zh-CN" sz="1200">
               <a:solidFill>
                 <a:schemeClr val="tx1"/>
               </a:solidFill>
@@ -6378,7 +6378,7 @@
               <a:defRPr/>
             </a:pPr>
             <a:r>
-              <a:rPr lang="zh-CN" sz="950">
+              <a:rPr lang="zh-CN" sz="1200">
                 <a:solidFill>
                   <a:schemeClr val="tx1"/>
                 </a:solidFill>
@@ -6388,7 +6388,7 @@
               </a:rPr>
               <a:t>发起读请求</a:t>
             </a:r>
-            <a:endParaRPr lang="zh-CN" sz="950">
+            <a:endParaRPr lang="zh-CN" sz="1200">
               <a:solidFill>
                 <a:schemeClr val="tx1"/>
               </a:solidFill>
@@ -6491,7 +6491,7 @@
               <a:defRPr/>
             </a:pPr>
             <a:r>
-              <a:rPr lang="zh-CN" sz="950">
+              <a:rPr lang="zh-CN" sz="1200">
                 <a:solidFill>
                   <a:schemeClr val="tx1"/>
                 </a:solidFill>
@@ -6501,7 +6501,7 @@
               </a:rPr>
               <a:t>进入文件系统</a:t>
             </a:r>
-            <a:endParaRPr lang="zh-CN" sz="950">
+            <a:endParaRPr lang="zh-CN" sz="1200">
               <a:solidFill>
                 <a:schemeClr val="tx1"/>
               </a:solidFill>
@@ -6604,7 +6604,7 @@
               <a:defRPr/>
             </a:pPr>
             <a:r>
-              <a:rPr lang="zh-CN" sz="950">
+              <a:rPr lang="zh-CN" sz="1200">
                 <a:solidFill>
                   <a:schemeClr val="tx1"/>
                 </a:solidFill>
@@ -6614,7 +6614,7 @@
               </a:rPr>
               <a:t>命中即返回</a:t>
             </a:r>
-            <a:endParaRPr lang="zh-CN" sz="950">
+            <a:endParaRPr lang="zh-CN" sz="1200">
               <a:solidFill>
                 <a:schemeClr val="tx1"/>
               </a:solidFill>
@@ -6717,7 +6717,7 @@
               <a:defRPr/>
             </a:pPr>
             <a:r>
-              <a:rPr lang="zh-CN" sz="950">
+              <a:rPr lang="zh-CN" sz="1200">
                 <a:solidFill>
                   <a:schemeClr val="tx1"/>
                 </a:solidFill>
@@ -6727,7 +6727,7 @@
               </a:rPr>
               <a:t>定位物理块</a:t>
             </a:r>
-            <a:endParaRPr lang="zh-CN" sz="950">
+            <a:endParaRPr lang="zh-CN" sz="1200">
               <a:solidFill>
                 <a:schemeClr val="tx1"/>
               </a:solidFill>
@@ -6830,7 +6830,7 @@
               <a:defRPr/>
             </a:pPr>
             <a:r>
-              <a:rPr lang="zh-CN" sz="950">
+              <a:rPr lang="zh-CN" sz="1200">
                 <a:solidFill>
                   <a:schemeClr val="tx1"/>
                 </a:solidFill>
@@ -6840,7 +6840,7 @@
               </a:rPr>
               <a:t>填充缓存并返回</a:t>
             </a:r>
-            <a:endParaRPr lang="zh-CN" sz="950">
+            <a:endParaRPr lang="zh-CN" sz="1200">
               <a:solidFill>
                 <a:schemeClr val="tx1"/>
               </a:solidFill>
@@ -9426,7 +9426,7 @@
         </p:nvSpPr>
         <p:spPr bwMode="auto">
           <a:xfrm>
-            <a:off x="2739960" y="2090323"/>
+            <a:off x="2736150" y="2010948"/>
             <a:ext cx="2596453" cy="846444"/>
           </a:xfrm>
         </p:spPr>
@@ -9779,7 +9779,7 @@
         </p:nvSpPr>
         <p:spPr bwMode="auto">
           <a:xfrm>
-            <a:off x="5735676" y="2325585"/>
+            <a:off x="5735041" y="2240495"/>
             <a:ext cx="3305610" cy="617479"/>
           </a:xfrm>
           <a:prstGeom prst="rect">
@@ -25767,64 +25767,56 @@
             </a:pPr>
             <a:r>
               <a:rPr lang="zh-CN" altLang="en-US" sz="1600">
-                <a:latin typeface="Arial" panose="020B0604020202020204"/>
-                <a:ea typeface="Arial" panose="020B0604020202020204"/>
-                <a:cs typeface="Arial" panose="020B0604020202020204"/>
+                <a:ea typeface="+mn-lt"/>
+                <a:cs typeface="+mn-lt"/>
               </a:rPr>
               <a:t>交互与执行工具</a:t>
             </a:r>
             <a:r>
               <a:rPr lang="en-US" sz="1600">
-                <a:latin typeface="Arial" panose="020B0604020202020204"/>
-                <a:ea typeface="Arial" panose="020B0604020202020204"/>
-                <a:cs typeface="Arial" panose="020B0604020202020204"/>
+                <a:ea typeface="+mn-lt"/>
+                <a:cs typeface="+mn-lt"/>
               </a:rPr>
               <a:t>	   </a:t>
             </a:r>
             <a:r>
               <a:rPr lang="en-US" altLang="zh-CN" sz="1600">
-                <a:latin typeface="Arial" panose="020B0604020202020204"/>
-                <a:ea typeface="Arial" panose="020B0604020202020204"/>
-                <a:cs typeface="Arial" panose="020B0604020202020204"/>
+                <a:ea typeface="+mn-lt"/>
+                <a:cs typeface="+mn-lt"/>
               </a:rPr>
               <a:t>Claude Code</a:t>
             </a:r>
             <a:r>
               <a:rPr lang="zh-CN" altLang="en-US" sz="1600">
-                <a:latin typeface="Arial" panose="020B0604020202020204"/>
-                <a:ea typeface="Arial" panose="020B0604020202020204"/>
-                <a:cs typeface="Arial" panose="020B0604020202020204"/>
+                <a:ea typeface="+mn-lt"/>
+                <a:cs typeface="+mn-lt"/>
               </a:rPr>
               <a:t>（命令行交互与执行</a:t>
             </a:r>
             <a:r>
               <a:rPr lang="en-US" altLang="zh-CN" sz="1600">
-                <a:latin typeface="Arial" panose="020B0604020202020204"/>
-                <a:ea typeface="Arial" panose="020B0604020202020204"/>
-                <a:cs typeface="Arial" panose="020B0604020202020204"/>
+                <a:ea typeface="+mn-lt"/>
+                <a:cs typeface="+mn-lt"/>
               </a:rPr>
               <a:t> harness</a:t>
             </a:r>
             <a:r>
               <a:rPr lang="zh-CN" altLang="en-US" sz="1600">
-                <a:latin typeface="Arial" panose="020B0604020202020204"/>
-                <a:ea typeface="宋体" panose="02010600030101010101" pitchFamily="2" charset="-122"/>
-                <a:cs typeface="Arial" panose="020B0604020202020204"/>
+                <a:ea typeface="+mn-lt"/>
+                <a:cs typeface="+mn-lt"/>
               </a:rPr>
               <a:t>）</a:t>
             </a:r>
             <a:r>
               <a:rPr lang="en-US" sz="1600">
-                <a:latin typeface="Arial" panose="020B0604020202020204"/>
-                <a:ea typeface="Arial" panose="020B0604020202020204"/>
-                <a:cs typeface="Arial" panose="020B0604020202020204"/>
+                <a:ea typeface="+mn-lt"/>
+                <a:cs typeface="+mn-lt"/>
               </a:rPr>
               <a:t>	</a:t>
             </a:r>
             <a:endParaRPr lang="en-US" sz="1600">
-              <a:latin typeface="Arial" panose="020B0604020202020204"/>
-              <a:ea typeface="Arial" panose="020B0604020202020204"/>
-              <a:cs typeface="Arial" panose="020B0604020202020204"/>
+              <a:ea typeface="+mn-lt"/>
+              <a:cs typeface="+mn-lt"/>
             </a:endParaRPr>
           </a:p>
           <a:p>
@@ -25838,32 +25830,28 @@
             </a:pPr>
             <a:r>
               <a:rPr lang="zh-CN" altLang="en-US" sz="1600">
-                <a:latin typeface="Arial" panose="020B0604020202020204"/>
-                <a:ea typeface="宋体" panose="02010600030101010101" pitchFamily="2" charset="-122"/>
-                <a:cs typeface="Arial" panose="020B0604020202020204"/>
+                <a:ea typeface="+mn-lt"/>
+                <a:cs typeface="+mn-lt"/>
               </a:rPr>
               <a:t>使用的大模型</a:t>
             </a:r>
             <a:r>
               <a:rPr lang="en-US" sz="1600">
-                <a:latin typeface="Arial" panose="020B0604020202020204"/>
-                <a:ea typeface="Arial" panose="020B0604020202020204"/>
-                <a:cs typeface="Arial" panose="020B0604020202020204"/>
+                <a:ea typeface="+mn-lt"/>
+                <a:cs typeface="+mn-lt"/>
               </a:rPr>
               <a:t>        </a:t>
             </a:r>
             <a:r>
               <a:rPr lang="en-US" altLang="zh-CN" sz="1600">
-                <a:latin typeface="Arial" panose="020B0604020202020204"/>
-                <a:ea typeface="Arial" panose="020B0604020202020204"/>
-                <a:cs typeface="Arial" panose="020B0604020202020204"/>
+                <a:ea typeface="+mn-lt"/>
+                <a:cs typeface="+mn-lt"/>
               </a:rPr>
               <a:t>DeepSeek V4 Pro</a:t>
             </a:r>
             <a:endParaRPr lang="en-US" altLang="zh-CN" sz="1600">
-              <a:latin typeface="Arial" panose="020B0604020202020204"/>
-              <a:ea typeface="Arial" panose="020B0604020202020204"/>
-              <a:cs typeface="Arial" panose="020B0604020202020204"/>
+              <a:ea typeface="+mn-lt"/>
+              <a:cs typeface="+mn-lt"/>
             </a:endParaRPr>
           </a:p>
           <a:p>
@@ -25877,30 +25865,28 @@
             </a:pPr>
             <a:r>
               <a:rPr lang="zh-CN" altLang="en-US" sz="1600">
-                <a:latin typeface="Arial" panose="020B0604020202020204"/>
-                <a:ea typeface="宋体" panose="02010600030101010101" pitchFamily="2" charset="-122"/>
-                <a:cs typeface="Arial" panose="020B0604020202020204"/>
+                <a:ea typeface="+mn-lt"/>
+                <a:cs typeface="+mn-lt"/>
               </a:rPr>
               <a:t>使用方式</a:t>
             </a:r>
             <a:r>
               <a:rPr lang="en-US" sz="1600">
-                <a:latin typeface="Arial" panose="020B0604020202020204"/>
-                <a:ea typeface="Arial" panose="020B0604020202020204"/>
-                <a:cs typeface="Arial" panose="020B0604020202020204"/>
+                <a:ea typeface="+mn-lt"/>
+                <a:cs typeface="+mn-lt"/>
               </a:rPr>
               <a:t>	   </a:t>
             </a:r>
             <a:r>
               <a:rPr lang="zh-CN" altLang="en-US">
-                <a:latin typeface="Arial" panose="020B0604020202020204"/>
-                <a:cs typeface="Arial" panose="020B0604020202020204"/>
+                <a:ea typeface="+mn-lt"/>
+                <a:cs typeface="+mn-lt"/>
               </a:rPr>
               <a:t>本地终端交互</a:t>
             </a:r>
             <a:endParaRPr lang="zh-CN" altLang="en-US">
-              <a:latin typeface="Arial" panose="020B0604020202020204"/>
-              <a:cs typeface="Arial" panose="020B0604020202020204"/>
+              <a:ea typeface="+mn-lt"/>
+              <a:cs typeface="+mn-lt"/>
             </a:endParaRPr>
           </a:p>
         </p:txBody>
@@ -26048,24 +26034,21 @@
                   <a:schemeClr val="tx1"/>
                 </a:solidFill>
                 <a:effectLst/>
-                <a:latin typeface="Arial" panose="020B0604020202020204"/>
-                <a:ea typeface="Arial" panose="020B0604020202020204"/>
-                <a:cs typeface="Arial" panose="020B0604020202020204"/>
+                <a:ea typeface="+mn-lt"/>
+                <a:cs typeface="+mn-lt"/>
               </a:rPr>
               <a:t>思路沟通与代码检查</a:t>
             </a:r>
             <a:r>
               <a:rPr lang="zh-CN" altLang="en-US" sz="1400">
-                <a:latin typeface="Arial" panose="020B0604020202020204"/>
-                <a:ea typeface="Arial" panose="020B0604020202020204"/>
-                <a:cs typeface="Arial" panose="020B0604020202020204"/>
+                <a:ea typeface="+mn-lt"/>
+                <a:cs typeface="+mn-lt"/>
               </a:rPr>
               <a:t>：围绕参赛队已经实现或准备实现的功能，讨论可能影响的模块、边界条件和风险点。</a:t>
             </a:r>
             <a:endParaRPr lang="en-US" sz="1400">
-              <a:latin typeface="Arial" panose="020B0604020202020204"/>
-              <a:ea typeface="Arial" panose="020B0604020202020204"/>
-              <a:cs typeface="Arial" panose="020B0604020202020204"/>
+              <a:ea typeface="+mn-lt"/>
+              <a:cs typeface="+mn-lt"/>
             </a:endParaRPr>
           </a:p>
           <a:p>
@@ -26079,40 +26062,35 @@
             </a:pPr>
             <a:r>
               <a:rPr lang="zh-CN" altLang="en-US" sz="1400" b="1">
-                <a:latin typeface="Arial" panose="020B0604020202020204"/>
-                <a:ea typeface="宋体" panose="02010600030101010101" pitchFamily="2" charset="-122"/>
-                <a:cs typeface="Arial" panose="020B0604020202020204"/>
+                <a:ea typeface="+mn-lt"/>
+                <a:cs typeface="+mn-lt"/>
               </a:rPr>
               <a:t>运行问题排查</a:t>
             </a:r>
             <a:r>
               <a:rPr lang="zh-CN" altLang="en-US" sz="1400">
-                <a:latin typeface="Arial" panose="020B0604020202020204"/>
-                <a:ea typeface="宋体" panose="02010600030101010101" pitchFamily="2" charset="-122"/>
-                <a:cs typeface="Arial" panose="020B0604020202020204"/>
+                <a:ea typeface="+mn-lt"/>
+                <a:cs typeface="+mn-lt"/>
               </a:rPr>
               <a:t>：当功能运行不正确、测试失败或出现</a:t>
             </a:r>
             <a:r>
               <a:rPr lang="en-US" altLang="zh-CN" sz="1400">
-                <a:latin typeface="Arial" panose="020B0604020202020204"/>
-                <a:ea typeface="宋体" panose="02010600030101010101" pitchFamily="2" charset="-122"/>
-                <a:cs typeface="Arial" panose="020B0604020202020204"/>
+                <a:ea typeface="+mn-lt"/>
+                <a:cs typeface="+mn-lt"/>
               </a:rPr>
               <a:t> panic/timeout </a:t>
             </a:r>
             <a:r>
               <a:rPr lang="zh-CN" altLang="en-US" sz="1400">
-                <a:latin typeface="Arial" panose="020B0604020202020204"/>
-                <a:ea typeface="宋体" panose="02010600030101010101" pitchFamily="2" charset="-122"/>
-                <a:cs typeface="Arial" panose="020B0604020202020204"/>
+                <a:ea typeface="+mn-lt"/>
+                <a:cs typeface="+mn-lt"/>
               </a:rPr>
               <a:t>时，辅助分析日志和报错信息。</a:t>
             </a:r>
             <a:endParaRPr lang="zh-CN" altLang="en-US" sz="1400">
-              <a:latin typeface="Arial" panose="020B0604020202020204"/>
-              <a:ea typeface="宋体" panose="02010600030101010101" pitchFamily="2" charset="-122"/>
-              <a:cs typeface="Arial" panose="020B0604020202020204"/>
+              <a:ea typeface="+mn-lt"/>
+              <a:cs typeface="+mn-lt"/>
             </a:endParaRPr>
           </a:p>
           <a:p>
@@ -26126,72 +26104,63 @@
             </a:pPr>
             <a:r>
               <a:rPr lang="zh-CN" altLang="en-US" sz="1400" b="1">
-                <a:latin typeface="Arial" panose="020B0604020202020204"/>
-                <a:ea typeface="宋体" panose="02010600030101010101" pitchFamily="2" charset="-122"/>
-                <a:cs typeface="Arial" panose="020B0604020202020204"/>
+                <a:ea typeface="+mn-lt"/>
+                <a:cs typeface="+mn-lt"/>
               </a:rPr>
               <a:t>自动化测试辅助</a:t>
             </a:r>
             <a:r>
               <a:rPr lang="zh-CN" altLang="en-US" sz="1400">
-                <a:latin typeface="Arial" panose="020B0604020202020204"/>
-                <a:ea typeface="宋体" panose="02010600030101010101" pitchFamily="2" charset="-122"/>
-                <a:cs typeface="Arial" panose="020B0604020202020204"/>
+                <a:ea typeface="+mn-lt"/>
+                <a:cs typeface="+mn-lt"/>
               </a:rPr>
               <a:t>：由于</a:t>
             </a:r>
             <a:r>
               <a:rPr lang="en-US" altLang="zh-CN" sz="1400">
-                <a:latin typeface="Arial" panose="020B0604020202020204"/>
-                <a:ea typeface="宋体" panose="02010600030101010101" pitchFamily="2" charset="-122"/>
-                <a:cs typeface="Arial" panose="020B0604020202020204"/>
+                <a:ea typeface="+mn-lt"/>
+                <a:cs typeface="+mn-lt"/>
               </a:rPr>
               <a:t> xfstests</a:t>
             </a:r>
             <a:r>
               <a:rPr lang="zh-CN" altLang="en-US" sz="1400">
-                <a:latin typeface="Arial" panose="020B0604020202020204"/>
-                <a:ea typeface="宋体" panose="02010600030101010101" pitchFamily="2" charset="-122"/>
-                <a:cs typeface="Arial" panose="020B0604020202020204"/>
+                <a:ea typeface="+mn-lt"/>
+                <a:cs typeface="+mn-lt"/>
               </a:rPr>
               <a:t>、</a:t>
             </a:r>
             <a:r>
               <a:rPr lang="en-US" altLang="zh-CN" sz="1400">
-                <a:latin typeface="Arial" panose="020B0604020202020204"/>
-                <a:ea typeface="宋体" panose="02010600030101010101" pitchFamily="2" charset="-122"/>
-                <a:cs typeface="Arial" panose="020B0604020202020204"/>
+                <a:ea typeface="+mn-lt"/>
+                <a:cs typeface="+mn-lt"/>
               </a:rPr>
               <a:t>fio </a:t>
             </a:r>
             <a:r>
               <a:rPr lang="zh-CN" altLang="en-US" sz="1400">
-                <a:latin typeface="Arial" panose="020B0604020202020204"/>
-                <a:ea typeface="宋体" panose="02010600030101010101" pitchFamily="2" charset="-122"/>
-                <a:cs typeface="Arial" panose="020B0604020202020204"/>
+                <a:ea typeface="+mn-lt"/>
+                <a:cs typeface="+mn-lt"/>
               </a:rPr>
               <a:t>等测试耗时较长，</a:t>
             </a:r>
             <a:r>
               <a:rPr lang="en-US" altLang="zh-CN" sz="1400">
-                <a:latin typeface="Arial" panose="020B0604020202020204"/>
-                <a:ea typeface="宋体" panose="02010600030101010101" pitchFamily="2" charset="-122"/>
-                <a:cs typeface="Arial" panose="020B0604020202020204"/>
+                <a:ea typeface="+mn-lt"/>
+                <a:cs typeface="+mn-lt"/>
               </a:rPr>
               <a:t>AI </a:t>
             </a:r>
             <a:r>
               <a:rPr lang="zh-CN" altLang="en-US" sz="1400">
-                <a:latin typeface="Arial" panose="020B0604020202020204"/>
-                <a:ea typeface="宋体" panose="02010600030101010101" pitchFamily="2" charset="-122"/>
-                <a:cs typeface="Arial" panose="020B0604020202020204"/>
+                <a:ea typeface="+mn-lt"/>
+                <a:cs typeface="+mn-lt"/>
               </a:rPr>
               <a:t>辅助编写测试脚本、整理运行命令，并按参赛队要求执行重复测试。</a:t>
             </a:r>
             <a:endParaRPr lang="zh-CN" altLang="en-US" sz="1400">
-              <a:latin typeface="Arial" panose="020B0604020202020204"/>
-              <a:ea typeface="宋体" panose="02010600030101010101" pitchFamily="2" charset="-122"/>
-              <a:cs typeface="Arial" panose="020B0604020202020204"/>
+              <a:ea typeface="+mn-lt"/>
+              <a:cs typeface="+mn-lt"/>
             </a:endParaRPr>
           </a:p>
           <a:p>
@@ -26205,56 +26174,49 @@
             </a:pPr>
             <a:r>
               <a:rPr lang="zh-CN" altLang="en-US" sz="1400" b="1">
-                <a:latin typeface="Arial" panose="020B0604020202020204"/>
-                <a:ea typeface="宋体" panose="02010600030101010101" pitchFamily="2" charset="-122"/>
-                <a:cs typeface="Arial" panose="020B0604020202020204"/>
+                <a:ea typeface="+mn-lt"/>
+                <a:cs typeface="+mn-lt"/>
               </a:rPr>
               <a:t>测试数据整理</a:t>
             </a:r>
             <a:r>
               <a:rPr lang="zh-CN" altLang="en-US" sz="1400">
-                <a:latin typeface="Arial" panose="020B0604020202020204"/>
-                <a:ea typeface="宋体" panose="02010600030101010101" pitchFamily="2" charset="-122"/>
-                <a:cs typeface="Arial" panose="020B0604020202020204"/>
+                <a:ea typeface="+mn-lt"/>
+                <a:cs typeface="+mn-lt"/>
               </a:rPr>
               <a:t>：将多轮</a:t>
             </a:r>
             <a:r>
               <a:rPr lang="en-US" altLang="zh-CN" sz="1400">
-                <a:latin typeface="Arial" panose="020B0604020202020204"/>
-                <a:ea typeface="宋体" panose="02010600030101010101" pitchFamily="2" charset="-122"/>
-                <a:cs typeface="Arial" panose="020B0604020202020204"/>
+                <a:ea typeface="+mn-lt"/>
+                <a:cs typeface="+mn-lt"/>
               </a:rPr>
               <a:t> benchmark</a:t>
             </a:r>
             <a:r>
               <a:rPr lang="zh-CN" altLang="en-US" sz="1400">
-                <a:latin typeface="Arial" panose="020B0604020202020204"/>
-                <a:ea typeface="宋体" panose="02010600030101010101" pitchFamily="2" charset="-122"/>
-                <a:cs typeface="Arial" panose="020B0604020202020204"/>
+                <a:ea typeface="+mn-lt"/>
+                <a:cs typeface="+mn-lt"/>
               </a:rPr>
               <a:t>、</a:t>
             </a:r>
             <a:r>
               <a:rPr lang="en-US" altLang="zh-CN" sz="1400">
-                <a:latin typeface="Arial" panose="020B0604020202020204"/>
-                <a:ea typeface="宋体" panose="02010600030101010101" pitchFamily="2" charset="-122"/>
-                <a:cs typeface="Arial" panose="020B0604020202020204"/>
+                <a:ea typeface="+mn-lt"/>
+                <a:cs typeface="+mn-lt"/>
               </a:rPr>
               <a:t>PASS/FAIL </a:t>
             </a:r>
             <a:r>
               <a:rPr lang="zh-CN" altLang="en-US" sz="1400">
-                <a:latin typeface="Arial" panose="020B0604020202020204"/>
-                <a:ea typeface="宋体" panose="02010600030101010101" pitchFamily="2" charset="-122"/>
-                <a:cs typeface="Arial" panose="020B0604020202020204"/>
+                <a:ea typeface="+mn-lt"/>
+                <a:cs typeface="+mn-lt"/>
               </a:rPr>
               <a:t>结果整理为表格，便于比较不同阶段的性能变化和正确性状态。</a:t>
             </a:r>
             <a:endParaRPr lang="zh-CN" altLang="en-US" sz="1400">
-              <a:latin typeface="Arial" panose="020B0604020202020204"/>
-              <a:ea typeface="宋体" panose="02010600030101010101" pitchFamily="2" charset="-122"/>
-              <a:cs typeface="Arial" panose="020B0604020202020204"/>
+              <a:ea typeface="+mn-lt"/>
+              <a:cs typeface="+mn-lt"/>
             </a:endParaRPr>
           </a:p>
           <a:p>
@@ -26268,19 +26230,25 @@
             </a:pPr>
             <a:r>
               <a:rPr lang="zh-CN" altLang="en-US" sz="1400" b="1">
+                <a:ea typeface="+mn-lt"/>
+                <a:cs typeface="+mn-lt"/>
+              </a:rPr>
+              <a:t>阶段状态总结</a:t>
+            </a:r>
+            <a:r>
+              <a:rPr lang="zh-CN" altLang="en-US" sz="1400">
+                <a:ea typeface="+mn-lt"/>
+                <a:cs typeface="+mn-lt"/>
+              </a:rPr>
+              <a:t>：根据当前代码状态，总结阶段完成情况、遗留问题和下一步计划，方便队内沟通</a:t>
+            </a:r>
+            <a:r>
+              <a:rPr lang="zh-CN" altLang="en-US" sz="1400">
                 <a:latin typeface="Arial" panose="020B0604020202020204"/>
                 <a:ea typeface="宋体" panose="02010600030101010101" pitchFamily="2" charset="-122"/>
                 <a:cs typeface="Arial" panose="020B0604020202020204"/>
               </a:rPr>
-              <a:t>阶段状态总结</a:t>
-            </a:r>
-            <a:r>
-              <a:rPr lang="zh-CN" altLang="en-US" sz="1400">
-                <a:latin typeface="Arial" panose="020B0604020202020204"/>
-                <a:ea typeface="宋体" panose="02010600030101010101" pitchFamily="2" charset="-122"/>
-                <a:cs typeface="Arial" panose="020B0604020202020204"/>
-              </a:rPr>
-              <a:t>：根据当前代码状态，总结阶段完成情况、遗留问题和下一步计划，方便队内沟通。</a:t>
+              <a:t>。</a:t>
             </a:r>
             <a:endParaRPr lang="zh-CN" altLang="en-US" sz="1400">
               <a:latin typeface="Arial" panose="020B0604020202020204"/>
@@ -31720,7 +31688,7 @@
         </p:nvSpPr>
         <p:spPr bwMode="auto">
           <a:xfrm>
-            <a:off x="2717800" y="2472690"/>
+            <a:off x="2717800" y="2259330"/>
             <a:ext cx="4432300" cy="3815714"/>
           </a:xfrm>
           <a:prstGeom prst="roundRect">
@@ -35859,7 +35827,7 @@
         <p:spPr bwMode="auto">
           <a:xfrm>
             <a:off x="4699000" y="2565400"/>
-            <a:ext cx="3111500" cy="212090"/>
+            <a:ext cx="3111500" cy="234950"/>
           </a:xfrm>
           <a:prstGeom prst="rect">
             <a:avLst/>
@@ -35878,7 +35846,7 @@
               <a:defRPr/>
             </a:pPr>
             <a:r>
-              <a:rPr lang="zh-CN" sz="1050" b="1">
+              <a:rPr lang="zh-CN" sz="1200" b="1">
                 <a:solidFill>
                   <a:srgbClr val="333333"/>
                 </a:solidFill>
@@ -35887,7 +35855,7 @@
               </a:rPr>
               <a:t>崩溃后只重放完整事务</a:t>
             </a:r>
-            <a:endParaRPr lang="zh-CN" sz="1050" b="1">
+            <a:endParaRPr lang="zh-CN" sz="1200" b="1">
               <a:solidFill>
                 <a:srgbClr val="333333"/>
               </a:solidFill>
@@ -35905,8 +35873,8 @@
         </p:nvSpPr>
         <p:spPr bwMode="auto">
           <a:xfrm>
-            <a:off x="8246110" y="2567940"/>
-            <a:ext cx="3238500" cy="212090"/>
+            <a:off x="8255000" y="2567940"/>
+            <a:ext cx="3238500" cy="234950"/>
           </a:xfrm>
           <a:prstGeom prst="rect">
             <a:avLst/>
@@ -35925,67 +35893,61 @@
               <a:defRPr/>
             </a:pPr>
             <a:r>
-              <a:rPr lang="zh-CN" sz="1050" b="1">
+              <a:rPr lang="zh-CN" sz="1200" b="1">
                 <a:solidFill>
                   <a:srgbClr val="333333"/>
                 </a:solidFill>
-                <a:latin typeface="+mn-ea"/>
-                <a:ea typeface="微软雅黑" panose="020B0503020204020204" charset="-122"/>
-                <a:cs typeface="+mn-ea"/>
+                <a:ea typeface="+mn-lt"/>
+                <a:cs typeface="+mn-lt"/>
               </a:rPr>
               <a:t>额外元数据</a:t>
             </a:r>
             <a:r>
-              <a:rPr lang="en-US" sz="1050" b="1">
+              <a:rPr lang="en-US" sz="1200" b="1">
                 <a:solidFill>
                   <a:srgbClr val="333333"/>
                 </a:solidFill>
-                <a:latin typeface="+mn-ea"/>
-                <a:ea typeface="微软雅黑" panose="020B0503020204020204" charset="-122"/>
-                <a:cs typeface="+mn-ea"/>
+                <a:ea typeface="+mn-lt"/>
+                <a:cs typeface="+mn-lt"/>
               </a:rPr>
               <a:t> I/O </a:t>
             </a:r>
             <a:r>
-              <a:rPr lang="zh-CN" sz="1050" b="1">
+              <a:rPr lang="zh-CN" sz="1200" b="1">
                 <a:solidFill>
                   <a:srgbClr val="333333"/>
                 </a:solidFill>
-                <a:latin typeface="+mn-ea"/>
-                <a:ea typeface="微软雅黑" panose="020B0503020204020204" charset="-122"/>
-                <a:cs typeface="+mn-ea"/>
+                <a:ea typeface="+mn-lt"/>
+                <a:cs typeface="+mn-lt"/>
               </a:rPr>
               <a:t>与</a:t>
             </a:r>
             <a:r>
-              <a:rPr lang="en-US" sz="1050" b="1">
+              <a:rPr lang="en-US" sz="1200" b="1">
                 <a:solidFill>
                   <a:srgbClr val="333333"/>
                 </a:solidFill>
-                <a:latin typeface="+mn-ea"/>
-                <a:ea typeface="微软雅黑" panose="020B0503020204020204" charset="-122"/>
-                <a:cs typeface="+mn-ea"/>
+                <a:ea typeface="+mn-lt"/>
+                <a:cs typeface="+mn-lt"/>
               </a:rPr>
               <a:t> checkpoint </a:t>
             </a:r>
             <a:r>
-              <a:rPr lang="zh-CN" sz="1050" b="1">
+              <a:rPr lang="zh-CN" sz="1200" b="1">
                 <a:solidFill>
                   <a:srgbClr val="333333"/>
                 </a:solidFill>
-                <a:latin typeface="+mn-ea"/>
-                <a:ea typeface="微软雅黑" panose="020B0503020204020204" charset="-122"/>
-                <a:cs typeface="+mn-ea"/>
+                <a:ea typeface="+mn-lt"/>
+                <a:cs typeface="+mn-lt"/>
               </a:rPr>
               <a:t>写回</a:t>
             </a:r>
-            <a:endParaRPr lang="zh-CN" sz="1050" b="1">
+            <a:endParaRPr lang="zh-CN" sz="1200" b="1">
               <a:solidFill>
                 <a:srgbClr val="333333"/>
               </a:solidFill>
-              <a:latin typeface="+mn-ea"/>
-              <a:ea typeface="微软雅黑" panose="020B0503020204020204" charset="-122"/>
-              <a:cs typeface="+mn-ea"/>
+              <a:ea typeface="+mn-lt"/>
+              <a:cs typeface="+mn-lt"/>
             </a:endParaRPr>
           </a:p>
         </p:txBody>
@@ -36164,8 +36126,8 @@
         </p:nvSpPr>
         <p:spPr bwMode="auto">
           <a:xfrm>
-            <a:off x="4699000" y="3291840"/>
-            <a:ext cx="3111500" cy="212090"/>
+            <a:off x="4704080" y="3265170"/>
+            <a:ext cx="3111500" cy="419735"/>
           </a:xfrm>
           <a:prstGeom prst="rect">
             <a:avLst/>
@@ -36184,7 +36146,7 @@
               <a:defRPr/>
             </a:pPr>
             <a:r>
-              <a:rPr lang="zh-CN" sz="1050" b="1">
+              <a:rPr lang="zh-CN" sz="1200" b="1">
                 <a:solidFill>
                   <a:srgbClr val="333333"/>
                 </a:solidFill>
@@ -36194,7 +36156,7 @@
               <a:t>约束提交顺序，避免写缓存乱序导致</a:t>
             </a:r>
             <a:r>
-              <a:rPr lang="en-US" sz="1050" b="1">
+              <a:rPr lang="en-US" sz="1200" b="1">
                 <a:solidFill>
                   <a:srgbClr val="333333"/>
                 </a:solidFill>
@@ -36204,7 +36166,7 @@
               <a:t> journal </a:t>
             </a:r>
             <a:r>
-              <a:rPr lang="zh-CN" sz="1050" b="1">
+              <a:rPr lang="zh-CN" sz="1200" b="1">
                 <a:solidFill>
                   <a:srgbClr val="333333"/>
                 </a:solidFill>
@@ -36213,7 +36175,7 @@
               </a:rPr>
               <a:t>失效</a:t>
             </a:r>
-            <a:endParaRPr lang="zh-CN" sz="1050" b="1">
+            <a:endParaRPr lang="zh-CN" sz="1200" b="1">
               <a:solidFill>
                 <a:srgbClr val="333333"/>
               </a:solidFill>
@@ -36232,7 +36194,7 @@
         <p:spPr bwMode="auto">
           <a:xfrm>
             <a:off x="8242300" y="3291840"/>
-            <a:ext cx="3238500" cy="212090"/>
+            <a:ext cx="3238500" cy="234950"/>
           </a:xfrm>
           <a:prstGeom prst="rect">
             <a:avLst/>
@@ -36251,22 +36213,20 @@
               <a:defRPr/>
             </a:pPr>
             <a:r>
-              <a:rPr lang="zh-CN" sz="1050" b="1">
+              <a:rPr lang="zh-CN" sz="1200" b="1">
                 <a:solidFill>
                   <a:srgbClr val="333333"/>
                 </a:solidFill>
-                <a:latin typeface="+mn-ea"/>
-                <a:ea typeface="微软雅黑" panose="020B0503020204020204" charset="-122"/>
+                <a:ea typeface="+mn-lt"/>
                 <a:cs typeface="+mn-ea"/>
               </a:rPr>
               <a:t>增加等待，降低高速设备并行度</a:t>
             </a:r>
-            <a:endParaRPr lang="zh-CN" sz="1050" b="1">
+            <a:endParaRPr lang="zh-CN" sz="1200" b="1">
               <a:solidFill>
                 <a:srgbClr val="333333"/>
               </a:solidFill>
-              <a:latin typeface="+mn-ea"/>
-              <a:ea typeface="微软雅黑" panose="020B0503020204020204" charset="-122"/>
+              <a:ea typeface="+mn-lt"/>
               <a:cs typeface="+mn-ea"/>
             </a:endParaRPr>
           </a:p>
@@ -36459,8 +36419,8 @@
         </p:nvSpPr>
         <p:spPr bwMode="auto">
           <a:xfrm>
-            <a:off x="4704080" y="4153535"/>
-            <a:ext cx="3111500" cy="212090"/>
+            <a:off x="4730750" y="4149725"/>
+            <a:ext cx="3111500" cy="234950"/>
           </a:xfrm>
           <a:prstGeom prst="rect">
             <a:avLst/>
@@ -36479,7 +36439,7 @@
               <a:defRPr/>
             </a:pPr>
             <a:r>
-              <a:rPr lang="zh-CN" sz="1050" b="1">
+              <a:rPr lang="zh-CN" sz="1200" b="1">
                 <a:solidFill>
                   <a:srgbClr val="333333"/>
                 </a:solidFill>
@@ -36487,7 +36447,7 @@
               </a:rPr>
               <a:t>给数据库事务提交提供明确持久化裁决点</a:t>
             </a:r>
-            <a:endParaRPr lang="zh-CN" sz="1050" b="1">
+            <a:endParaRPr lang="zh-CN" sz="1200" b="1">
               <a:solidFill>
                 <a:srgbClr val="333333"/>
               </a:solidFill>
@@ -36505,7 +36465,7 @@
         <p:spPr bwMode="auto">
           <a:xfrm>
             <a:off x="8255000" y="4172585"/>
-            <a:ext cx="3238500" cy="212090"/>
+            <a:ext cx="3238500" cy="234950"/>
           </a:xfrm>
           <a:prstGeom prst="rect">
             <a:avLst/>
@@ -36524,21 +36484,19 @@
               <a:defRPr/>
             </a:pPr>
             <a:r>
-              <a:rPr lang="zh-CN" sz="1050" b="1">
+              <a:rPr lang="zh-CN" sz="1200" b="1">
                 <a:solidFill>
                   <a:srgbClr val="333333"/>
                 </a:solidFill>
-                <a:latin typeface="+mn-ea"/>
-                <a:ea typeface="微软雅黑" panose="020B0503020204020204" charset="-122"/>
+                <a:ea typeface="+mn-lt"/>
               </a:rPr>
               <a:t>同步等待脏页和事务提交，延迟被放大</a:t>
             </a:r>
-            <a:endParaRPr lang="zh-CN" sz="1050" b="1">
+            <a:endParaRPr lang="zh-CN" sz="1200" b="1">
               <a:solidFill>
                 <a:srgbClr val="333333"/>
               </a:solidFill>
-              <a:latin typeface="+mn-ea"/>
-              <a:ea typeface="微软雅黑" panose="020B0503020204020204" charset="-122"/>
+              <a:ea typeface="+mn-lt"/>
             </a:endParaRPr>
           </a:p>
         </p:txBody>
@@ -36718,7 +36676,7 @@
         <p:spPr bwMode="auto">
           <a:xfrm>
             <a:off x="4704080" y="5015865"/>
-            <a:ext cx="3111500" cy="373380"/>
+            <a:ext cx="3111500" cy="419735"/>
           </a:xfrm>
           <a:prstGeom prst="rect">
             <a:avLst/>
@@ -36737,7 +36695,7 @@
               <a:defRPr/>
             </a:pPr>
             <a:r>
-              <a:rPr lang="zh-CN" sz="1050" b="1">
+              <a:rPr lang="zh-CN" sz="1200" b="1">
                 <a:solidFill>
                   <a:srgbClr val="333333"/>
                 </a:solidFill>
@@ -36747,7 +36705,7 @@
               <a:t>保护目录、</a:t>
             </a:r>
             <a:r>
-              <a:rPr lang="en-US" sz="1050" b="1">
+              <a:rPr lang="en-US" sz="1200" b="1">
                 <a:solidFill>
                   <a:srgbClr val="333333"/>
                 </a:solidFill>
@@ -36757,7 +36715,7 @@
               <a:t>inode</a:t>
             </a:r>
             <a:r>
-              <a:rPr lang="zh-CN" sz="1050" b="1">
+              <a:rPr lang="zh-CN" sz="1200" b="1">
                 <a:solidFill>
                   <a:srgbClr val="333333"/>
                 </a:solidFill>
@@ -36767,7 +36725,7 @@
               <a:t>、</a:t>
             </a:r>
             <a:r>
-              <a:rPr lang="en-US" sz="1050" b="1">
+              <a:rPr lang="en-US" sz="1200" b="1">
                 <a:solidFill>
                   <a:srgbClr val="333333"/>
                 </a:solidFill>
@@ -36777,7 +36735,7 @@
               <a:t>extent</a:t>
             </a:r>
             <a:r>
-              <a:rPr lang="zh-CN" sz="1050" b="1">
+              <a:rPr lang="zh-CN" sz="1200" b="1">
                 <a:solidFill>
                   <a:srgbClr val="333333"/>
                 </a:solidFill>
@@ -36787,7 +36745,7 @@
               <a:t>、</a:t>
             </a:r>
             <a:r>
-              <a:rPr lang="en-US" sz="1050" b="1">
+              <a:rPr lang="en-US" sz="1200" b="1">
                 <a:solidFill>
                   <a:srgbClr val="333333"/>
                 </a:solidFill>
@@ -36797,7 +36755,7 @@
               <a:t>PageCache </a:t>
             </a:r>
             <a:r>
-              <a:rPr lang="zh-CN" sz="1050" b="1">
+              <a:rPr lang="zh-CN" sz="1200" b="1">
                 <a:solidFill>
                   <a:srgbClr val="333333"/>
                 </a:solidFill>
@@ -36807,7 +36765,7 @@
               <a:t>与</a:t>
             </a:r>
             <a:r>
-              <a:rPr lang="en-US" sz="1050" b="1">
+              <a:rPr lang="en-US" sz="1200" b="1">
                 <a:solidFill>
                   <a:srgbClr val="333333"/>
                 </a:solidFill>
@@ -36817,7 +36775,7 @@
               <a:t> journal </a:t>
             </a:r>
             <a:r>
-              <a:rPr lang="zh-CN" sz="1050" b="1">
+              <a:rPr lang="zh-CN" sz="1200" b="1">
                 <a:solidFill>
                   <a:srgbClr val="333333"/>
                 </a:solidFill>
@@ -36826,7 +36784,7 @@
               </a:rPr>
               <a:t>状态一致</a:t>
             </a:r>
-            <a:endParaRPr lang="zh-CN" sz="1050" b="1">
+            <a:endParaRPr lang="zh-CN" sz="1200" b="1">
               <a:solidFill>
                 <a:srgbClr val="333333"/>
               </a:solidFill>
@@ -36845,7 +36803,7 @@
         <p:spPr bwMode="auto">
           <a:xfrm>
             <a:off x="8255000" y="5053330"/>
-            <a:ext cx="3238500" cy="212090"/>
+            <a:ext cx="3238500" cy="234950"/>
           </a:xfrm>
           <a:prstGeom prst="rect">
             <a:avLst/>
@@ -36864,45 +36822,41 @@
               <a:defRPr/>
             </a:pPr>
             <a:r>
-              <a:rPr lang="zh-CN" sz="1050" b="1">
+              <a:rPr lang="zh-CN" sz="1200" b="1">
                 <a:solidFill>
                   <a:srgbClr val="333333"/>
                 </a:solidFill>
-                <a:latin typeface="+mn-ea"/>
-                <a:ea typeface="微软雅黑" panose="020B0503020204020204" charset="-122"/>
-                <a:cs typeface="+mn-ea"/>
+                <a:ea typeface="+mn-lt"/>
+                <a:cs typeface="+mn-lt"/>
               </a:rPr>
               <a:t>粗粒度锁或频繁失效会削弱并发</a:t>
             </a:r>
             <a:r>
-              <a:rPr lang="en-US" sz="1050" b="1">
+              <a:rPr lang="en-US" sz="1200" b="1">
                 <a:solidFill>
                   <a:srgbClr val="333333"/>
                 </a:solidFill>
-                <a:latin typeface="+mn-ea"/>
-                <a:ea typeface="微软雅黑" panose="020B0503020204020204" charset="-122"/>
-                <a:cs typeface="+mn-ea"/>
+                <a:ea typeface="+mn-lt"/>
+                <a:cs typeface="+mn-lt"/>
               </a:rPr>
               <a:t> I/O </a:t>
             </a:r>
             <a:r>
-              <a:rPr lang="zh-CN" sz="1050" b="1">
+              <a:rPr lang="zh-CN" sz="1200" b="1">
                 <a:solidFill>
                   <a:srgbClr val="333333"/>
                 </a:solidFill>
-                <a:latin typeface="+mn-ea"/>
-                <a:ea typeface="微软雅黑" panose="020B0503020204020204" charset="-122"/>
-                <a:cs typeface="+mn-ea"/>
+                <a:ea typeface="+mn-lt"/>
+                <a:cs typeface="+mn-lt"/>
               </a:rPr>
               <a:t>扩展性</a:t>
             </a:r>
-            <a:endParaRPr lang="zh-CN" sz="1050" b="1">
+            <a:endParaRPr lang="zh-CN" sz="1200" b="1">
               <a:solidFill>
                 <a:srgbClr val="333333"/>
               </a:solidFill>
-              <a:latin typeface="+mn-ea"/>
-              <a:ea typeface="微软雅黑" panose="020B0503020204020204" charset="-122"/>
-              <a:cs typeface="+mn-ea"/>
+              <a:ea typeface="+mn-lt"/>
+              <a:cs typeface="+mn-lt"/>
             </a:endParaRPr>
           </a:p>
         </p:txBody>
@@ -38472,9 +38426,8 @@
                 <a:solidFill>
                   <a:srgbClr val="333333"/>
                 </a:solidFill>
-                <a:latin typeface="+mn-ea"/>
-                <a:ea typeface="微软雅黑" panose="020B0503020204020204" charset="-122"/>
-                <a:cs typeface="+mn-ea"/>
+                <a:ea typeface="+mn-lt"/>
+                <a:cs typeface="+mn-lt"/>
               </a:rPr>
               <a:t>对接</a:t>
             </a:r>
@@ -38483,9 +38436,8 @@
                 <a:solidFill>
                   <a:srgbClr val="333333"/>
                 </a:solidFill>
-                <a:latin typeface="+mn-ea"/>
-                <a:ea typeface="微软雅黑" panose="020B0503020204020204" charset="-122"/>
-                <a:cs typeface="+mn-ea"/>
+                <a:ea typeface="+mn-lt"/>
+                <a:cs typeface="+mn-lt"/>
               </a:rPr>
               <a:t> VFS / PageCache / block device</a:t>
             </a:r>
@@ -38494,9 +38446,8 @@
                 <a:solidFill>
                   <a:srgbClr val="333333"/>
                 </a:solidFill>
-                <a:latin typeface="+mn-ea"/>
-                <a:ea typeface="微软雅黑" panose="020B0503020204020204" charset="-122"/>
-                <a:cs typeface="+mn-ea"/>
+                <a:ea typeface="+mn-lt"/>
+                <a:cs typeface="+mn-lt"/>
               </a:rPr>
               <a:t>，支持真实应用</a:t>
             </a:r>
@@ -38504,9 +38455,8 @@
               <a:solidFill>
                 <a:srgbClr val="333333"/>
               </a:solidFill>
-              <a:latin typeface="+mn-ea"/>
-              <a:ea typeface="微软雅黑" panose="020B0503020204020204" charset="-122"/>
-              <a:cs typeface="+mn-ea"/>
+              <a:ea typeface="+mn-lt"/>
+              <a:cs typeface="+mn-lt"/>
             </a:endParaRPr>
           </a:p>
         </p:txBody>
@@ -38721,9 +38671,8 @@
                 <a:solidFill>
                   <a:srgbClr val="333333"/>
                 </a:solidFill>
-                <a:latin typeface="+mn-ea"/>
-                <a:ea typeface="微软雅黑" panose="020B0503020204020204" charset="-122"/>
-                <a:cs typeface="+mn-ea"/>
+                <a:ea typeface="+mn-lt"/>
+                <a:cs typeface="+mn-lt"/>
               </a:rPr>
               <a:t>JBD2 ordered</a:t>
             </a:r>
@@ -38732,9 +38681,8 @@
                 <a:solidFill>
                   <a:srgbClr val="333333"/>
                 </a:solidFill>
-                <a:latin typeface="+mn-ea"/>
-                <a:ea typeface="微软雅黑" panose="020B0503020204020204" charset="-122"/>
-                <a:cs typeface="+mn-ea"/>
+                <a:ea typeface="+mn-lt"/>
+                <a:cs typeface="+mn-lt"/>
               </a:rPr>
               <a:t>、</a:t>
             </a:r>
@@ -38743,9 +38691,8 @@
                 <a:solidFill>
                   <a:srgbClr val="333333"/>
                 </a:solidFill>
-                <a:latin typeface="+mn-ea"/>
-                <a:ea typeface="微软雅黑" panose="020B0503020204020204" charset="-122"/>
-                <a:cs typeface="+mn-ea"/>
+                <a:ea typeface="+mn-lt"/>
+                <a:cs typeface="+mn-lt"/>
               </a:rPr>
               <a:t>fsync</a:t>
             </a:r>
@@ -38754,9 +38701,8 @@
                 <a:solidFill>
                   <a:srgbClr val="333333"/>
                 </a:solidFill>
-                <a:latin typeface="+mn-ea"/>
-                <a:ea typeface="微软雅黑" panose="020B0503020204020204" charset="-122"/>
-                <a:cs typeface="+mn-ea"/>
+                <a:ea typeface="+mn-lt"/>
+                <a:cs typeface="+mn-lt"/>
               </a:rPr>
               <a:t>、</a:t>
             </a:r>
@@ -38765,9 +38711,8 @@
                 <a:solidFill>
                   <a:srgbClr val="333333"/>
                 </a:solidFill>
-                <a:latin typeface="+mn-ea"/>
-                <a:ea typeface="微软雅黑" panose="020B0503020204020204" charset="-122"/>
-                <a:cs typeface="+mn-ea"/>
+                <a:ea typeface="+mn-lt"/>
+                <a:cs typeface="+mn-lt"/>
               </a:rPr>
               <a:t>recovery </a:t>
             </a:r>
@@ -38776,9 +38721,8 @@
                 <a:solidFill>
                   <a:srgbClr val="333333"/>
                 </a:solidFill>
-                <a:latin typeface="+mn-ea"/>
-                <a:ea typeface="微软雅黑" panose="020B0503020204020204" charset="-122"/>
-                <a:cs typeface="+mn-ea"/>
+                <a:ea typeface="+mn-lt"/>
+                <a:cs typeface="+mn-lt"/>
               </a:rPr>
               <a:t>保证崩溃后可恢复</a:t>
             </a:r>
@@ -38786,9 +38730,8 @@
               <a:solidFill>
                 <a:srgbClr val="333333"/>
               </a:solidFill>
-              <a:latin typeface="+mn-ea"/>
-              <a:ea typeface="微软雅黑" panose="020B0503020204020204" charset="-122"/>
-              <a:cs typeface="+mn-ea"/>
+              <a:ea typeface="+mn-lt"/>
+              <a:cs typeface="+mn-lt"/>
             </a:endParaRPr>
           </a:p>
         </p:txBody>
@@ -39003,8 +38946,7 @@
                 <a:solidFill>
                   <a:srgbClr val="333333"/>
                 </a:solidFill>
-                <a:latin typeface="+mn-ea"/>
-                <a:ea typeface="微软雅黑" panose="020B0503020204020204" charset="-122"/>
+                <a:ea typeface="+mn-lt"/>
                 <a:cs typeface="+mn-ea"/>
               </a:rPr>
               <a:t>缓存、日志、锁的优化</a:t>
@@ -39013,8 +38955,7 @@
               <a:solidFill>
                 <a:srgbClr val="333333"/>
               </a:solidFill>
-              <a:latin typeface="+mn-ea"/>
-              <a:ea typeface="微软雅黑" panose="020B0503020204020204" charset="-122"/>
+              <a:ea typeface="+mn-lt"/>
               <a:cs typeface="+mn-ea"/>
             </a:endParaRPr>
           </a:p>

</xml_diff>